<commit_message>
docs: remove em dashes from presentation slides and notes
</commit_message>
<xml_diff>
--- a/docs/PRESENTATION.pptx
+++ b/docs/PRESENTATION.pptx
@@ -5572,7 +5572,7 @@
               </a:defRPr>
             </a:pPr>
             <a:r>
-              <a:t>Trust the checks—not a claim.</a:t>
+              <a:t>Trust the checks - not a claim.</a:t>
             </a:r>
           </a:p>
         </p:txBody>
@@ -8676,7 +8676,7 @@
               </a:defRPr>
             </a:pPr>
             <a:r>
-              <a:t>A pattern is a reason to look closer—not proof of wrongdoing.</a:t>
+              <a:t>A pattern is a reason to look closer - not proof of wrongdoing.</a:t>
             </a:r>
           </a:p>
         </p:txBody>
@@ -13886,7 +13886,7 @@
               </a:defRPr>
             </a:pPr>
             <a:r>
-              <a:t>Observed transfers—not a balance or a complete account history.</a:t>
+              <a:t>Observed transfers - not a balance or a complete account history.</a:t>
             </a:r>
           </a:p>
         </p:txBody>
@@ -15008,7 +15008,7 @@
               </a:defRPr>
             </a:pPr>
             <a:r>
-              <a:t>Illustrative sequence—not a measured transaction from the dataset.</a:t>
+              <a:t>Illustrative sequence - not a measured transaction from the dataset.</a:t>
             </a:r>
           </a:p>
         </p:txBody>
@@ -16038,7 +16038,7 @@
               </a:defRPr>
             </a:pPr>
             <a:r>
-              <a:t>LIVE DEMO / Review &amp; audit — use the demo database only</a:t>
+              <a:t>LIVE DEMO / Review &amp; audit - use the demo database only</a:t>
             </a:r>
           </a:p>
         </p:txBody>

</xml_diff>